<commit_message>
Rebuild strategy scheme after lecture: PEST and internal factors into SWOT, four strategies
Co-Authored-By: Claude Sonnet 5.5 <noreply@anthropic.com>
Claude-Session: https://claude.ai/code/session_01PfagTkBBfn3ShTm5bX9M45
</commit_message>
<xml_diff>
--- a/slide_shema_diagnostika_strategii.pptx
+++ b/slide_shema_diagnostika_strategii.pptx
@@ -430,7 +430,7 @@
           <a:lstStyle/>
           <a:p>
             <a:r>
-              <a:t>Слайд пересобран из прежнего слайда «Принципиальная схема диагностики». Блоки диагностики соответствуют разделам лекции 02, 04 по 09. Формулировки четырёх стратегий (рост, укрепление, сдерживание, сжатие) и их краткие описания написаны при оформлении и требуют сверки с принятой в институте методикой.</a:t>
+              <a:t>Схема построена по лекции про SWOT и PEST (слайды 3, 10 и 11). Названия и описания четырёх стратегий (рост, защита, укрепление, сжатие) взяты со слайда 11 лекции. Блоки диагностики соответствуют разделам основной лекции, тип территории вынесен в итог диагностики. Внутренние факторы (S и W) выводятся из итогов диагностики, внешние (O и T) из PEST.</a:t>
             </a:r>
           </a:p>
         </p:txBody>
@@ -6289,7 +6289,7 @@
                 </a:solidFill>
                 <a:latin typeface="Circe"/>
               </a:rPr>
-              <a:t>Принципиальная схема. После диагностики и анализа среды открывается дерево возможностей</a:t>
+              <a:t>Принципиальная схема. После диагностики стратегический анализ определяет одну из четырёх стратегий</a:t>
             </a:r>
             <a:endParaRPr sz="2200" b="0" dirty="0">
               <a:solidFill>
@@ -6309,7 +6309,7 @@
         <p:spPr>
           <a:xfrm>
             <a:off x="1069848" y="2331720"/>
-            <a:ext cx="4846320" cy="502920"/>
+            <a:ext cx="4572000" cy="502920"/>
           </a:xfrm>
           <a:prstGeom prst="rect">
             <a:avLst/>
@@ -6347,7 +6347,7 @@
         <p:spPr>
           <a:xfrm>
             <a:off x="1069848" y="2880360"/>
-            <a:ext cx="4846320" cy="292608"/>
+            <a:ext cx="4572000" cy="292608"/>
           </a:xfrm>
           <a:prstGeom prst="rect">
             <a:avLst/>
@@ -6381,7 +6381,7 @@
         </p:nvSpPr>
         <p:spPr>
           <a:xfrm>
-            <a:off x="1115568" y="3410711"/>
+            <a:off x="1115568" y="3401568"/>
             <a:ext cx="457200" cy="457200"/>
           </a:xfrm>
           <a:prstGeom prst="ellipse">
@@ -6420,7 +6420,7 @@
         <p:spPr>
           <a:xfrm>
             <a:off x="1801368" y="3291839"/>
-            <a:ext cx="4114800" cy="694944"/>
+            <a:ext cx="3840480" cy="676656"/>
           </a:xfrm>
           <a:prstGeom prst="rect">
             <a:avLst/>
@@ -6441,7 +6441,7 @@
                 </a:solidFill>
                 <a:latin typeface="Circe Bold"/>
               </a:rPr>
-              <a:t>Типология сельских территорий</a:t>
+              <a:t>Природно-ресурсный потенциал</a:t>
             </a:r>
           </a:p>
         </p:txBody>
@@ -6454,8 +6454,8 @@
         </p:nvCxnSpPr>
         <p:spPr>
           <a:xfrm>
-            <a:off x="1069848" y="3986783"/>
-            <a:ext cx="4846320" cy="0"/>
+            <a:off x="1069848" y="3968496"/>
+            <a:ext cx="4572000" cy="0"/>
           </a:xfrm>
           <a:prstGeom prst="line">
             <a:avLst/>
@@ -6475,7 +6475,7 @@
         </p:nvSpPr>
         <p:spPr>
           <a:xfrm>
-            <a:off x="1115568" y="4105655"/>
+            <a:off x="1115568" y="4078224"/>
             <a:ext cx="457200" cy="457200"/>
           </a:xfrm>
           <a:prstGeom prst="ellipse">
@@ -6513,8 +6513,8 @@
         </p:nvSpPr>
         <p:spPr>
           <a:xfrm>
-            <a:off x="1801368" y="3986783"/>
-            <a:ext cx="4114800" cy="694944"/>
+            <a:off x="1801368" y="3968496"/>
+            <a:ext cx="3840480" cy="676656"/>
           </a:xfrm>
           <a:prstGeom prst="rect">
             <a:avLst/>
@@ -6535,7 +6535,7 @@
                 </a:solidFill>
                 <a:latin typeface="Circe Bold"/>
               </a:rPr>
-              <a:t>Природно-ресурсный потенциал</a:t>
+              <a:t>Население и человеческий потенциал</a:t>
             </a:r>
           </a:p>
         </p:txBody>
@@ -6548,8 +6548,8 @@
         </p:nvCxnSpPr>
         <p:spPr>
           <a:xfrm>
-            <a:off x="1069848" y="4681727"/>
-            <a:ext cx="4846320" cy="0"/>
+            <a:off x="1069848" y="4645152"/>
+            <a:ext cx="4572000" cy="0"/>
           </a:xfrm>
           <a:prstGeom prst="line">
             <a:avLst/>
@@ -6569,7 +6569,7 @@
         </p:nvSpPr>
         <p:spPr>
           <a:xfrm>
-            <a:off x="1115568" y="4800599"/>
+            <a:off x="1115568" y="4754880"/>
             <a:ext cx="457200" cy="457200"/>
           </a:xfrm>
           <a:prstGeom prst="ellipse">
@@ -6607,8 +6607,8 @@
         </p:nvSpPr>
         <p:spPr>
           <a:xfrm>
-            <a:off x="1801368" y="4681727"/>
-            <a:ext cx="4114800" cy="694944"/>
+            <a:off x="1801368" y="4645152"/>
+            <a:ext cx="3840480" cy="676656"/>
           </a:xfrm>
           <a:prstGeom prst="rect">
             <a:avLst/>
@@ -6629,7 +6629,7 @@
                 </a:solidFill>
                 <a:latin typeface="Circe Bold"/>
               </a:rPr>
-              <a:t>Население и человеческий потенциал</a:t>
+              <a:t>Экономика, занятость и доходы населения</a:t>
             </a:r>
           </a:p>
         </p:txBody>
@@ -6642,8 +6642,8 @@
         </p:nvCxnSpPr>
         <p:spPr>
           <a:xfrm>
-            <a:off x="1069848" y="5376671"/>
-            <a:ext cx="4846320" cy="0"/>
+            <a:off x="1069848" y="5321808"/>
+            <a:ext cx="4572000" cy="0"/>
           </a:xfrm>
           <a:prstGeom prst="line">
             <a:avLst/>
@@ -6663,7 +6663,7 @@
         </p:nvSpPr>
         <p:spPr>
           <a:xfrm>
-            <a:off x="1115568" y="5495543"/>
+            <a:off x="1115568" y="5431536"/>
             <a:ext cx="457200" cy="457200"/>
           </a:xfrm>
           <a:prstGeom prst="ellipse">
@@ -6701,8 +6701,8 @@
         </p:nvSpPr>
         <p:spPr>
           <a:xfrm>
-            <a:off x="1801368" y="5376671"/>
-            <a:ext cx="4114800" cy="694944"/>
+            <a:off x="1801368" y="5321808"/>
+            <a:ext cx="3840480" cy="676656"/>
           </a:xfrm>
           <a:prstGeom prst="rect">
             <a:avLst/>
@@ -6723,7 +6723,7 @@
                 </a:solidFill>
                 <a:latin typeface="Circe Bold"/>
               </a:rPr>
-              <a:t>Экономика, занятость и доходы населения</a:t>
+              <a:t>Качество жизни и инфраструктура</a:t>
             </a:r>
           </a:p>
         </p:txBody>
@@ -6736,8 +6736,8 @@
         </p:nvCxnSpPr>
         <p:spPr>
           <a:xfrm>
-            <a:off x="1069848" y="6071615"/>
-            <a:ext cx="4846320" cy="0"/>
+            <a:off x="1069848" y="5998464"/>
+            <a:ext cx="4572000" cy="0"/>
           </a:xfrm>
           <a:prstGeom prst="line">
             <a:avLst/>
@@ -6757,7 +6757,7 @@
         </p:nvSpPr>
         <p:spPr>
           <a:xfrm>
-            <a:off x="1115568" y="6190487"/>
+            <a:off x="1115568" y="6108192"/>
             <a:ext cx="457200" cy="457200"/>
           </a:xfrm>
           <a:prstGeom prst="ellipse">
@@ -6795,8 +6795,8 @@
         </p:nvSpPr>
         <p:spPr>
           <a:xfrm>
-            <a:off x="1801368" y="6071615"/>
-            <a:ext cx="4114800" cy="694944"/>
+            <a:off x="1801368" y="5998464"/>
+            <a:ext cx="3840480" cy="676656"/>
           </a:xfrm>
           <a:prstGeom prst="rect">
             <a:avLst/>
@@ -6817,7 +6817,7 @@
                 </a:solidFill>
                 <a:latin typeface="Circe Bold"/>
               </a:rPr>
-              <a:t>Качество жизни и инфраструктура</a:t>
+              <a:t>Пространственные ресурсы и ограничения</a:t>
             </a:r>
           </a:p>
         </p:txBody>
@@ -6830,8 +6830,8 @@
         </p:nvCxnSpPr>
         <p:spPr>
           <a:xfrm>
-            <a:off x="1069848" y="6766559"/>
-            <a:ext cx="4846320" cy="0"/>
+            <a:off x="1069848" y="6675120"/>
+            <a:ext cx="4572000" cy="0"/>
           </a:xfrm>
           <a:prstGeom prst="line">
             <a:avLst/>
@@ -6851,7 +6851,7 @@
         </p:nvSpPr>
         <p:spPr>
           <a:xfrm>
-            <a:off x="1115568" y="6885431"/>
+            <a:off x="1115568" y="6784848"/>
             <a:ext cx="457200" cy="457200"/>
           </a:xfrm>
           <a:prstGeom prst="ellipse">
@@ -6889,102 +6889,8 @@
         </p:nvSpPr>
         <p:spPr>
           <a:xfrm>
-            <a:off x="1801368" y="6766559"/>
-            <a:ext cx="4114800" cy="694944"/>
-          </a:xfrm>
-          <a:prstGeom prst="rect">
-            <a:avLst/>
-          </a:prstGeom>
-          <a:noFill/>
-        </p:spPr>
-        <p:txBody>
-          <a:bodyPr wrap="square" anchor="ctr" lIns="0" rIns="0" tIns="0" bIns="0">
-            <a:spAutoFit/>
-          </a:bodyPr>
-          <a:lstStyle/>
-          <a:p>
-            <a:pPr algn="l"/>
-            <a:r>
-              <a:rPr sz="1600" b="1">
-                <a:solidFill>
-                  <a:srgbClr val="062D3F"/>
-                </a:solidFill>
-                <a:latin typeface="Circe Bold"/>
-              </a:rPr>
-              <a:t>Пространственные ресурсы и ограничения</a:t>
-            </a:r>
-          </a:p>
-        </p:txBody>
-      </p:sp>
-      <p:cxnSp>
-        <p:nvCxnSpPr>
-          <p:cNvPr id="222" name="Разделитель"/>
-          <p:cNvCxnSpPr/>
-          <p:nvPr/>
-        </p:nvCxnSpPr>
-        <p:spPr>
-          <a:xfrm>
-            <a:off x="1069848" y="7461503"/>
-            <a:ext cx="4846320" cy="0"/>
-          </a:xfrm>
-          <a:prstGeom prst="line">
-            <a:avLst/>
-          </a:prstGeom>
-          <a:ln w="12700">
-            <a:solidFill>
-              <a:srgbClr val="D9DEE2"/>
-            </a:solidFill>
-          </a:ln>
-        </p:spPr>
-      </p:cxnSp>
-      <p:sp>
-        <p:nvSpPr>
-          <p:cNvPr id="223" name="Номер 7"/>
-          <p:cNvSpPr/>
-          <p:nvPr/>
-        </p:nvSpPr>
-        <p:spPr>
-          <a:xfrm>
-            <a:off x="1115568" y="7580375"/>
-            <a:ext cx="457200" cy="457200"/>
-          </a:xfrm>
-          <a:prstGeom prst="ellipse">
-            <a:avLst/>
-          </a:prstGeom>
-          <a:solidFill>
-            <a:srgbClr val="FFCC00"/>
-          </a:solidFill>
-          <a:ln>
-            <a:noFill/>
-          </a:ln>
-        </p:spPr>
-        <p:txBody>
-          <a:bodyPr rtlCol="0" anchor="ctr" wrap="square" lIns="0" rIns="0" tIns="0" bIns="0"/>
-          <a:lstStyle/>
-          <a:p>
-            <a:pPr algn="ctr"/>
-            <a:r>
-              <a:rPr sz="1600" b="1">
-                <a:solidFill>
-                  <a:srgbClr val="062D3F"/>
-                </a:solidFill>
-                <a:latin typeface="Circe Bold"/>
-              </a:rPr>
-              <a:t>7</a:t>
-            </a:r>
-          </a:p>
-        </p:txBody>
-      </p:sp>
-      <p:sp>
-        <p:nvSpPr>
-          <p:cNvPr id="224" name="Блок 7"/>
-          <p:cNvSpPr txBox="1"/>
-          <p:nvPr/>
-        </p:nvSpPr>
-        <p:spPr>
-          <a:xfrm>
-            <a:off x="1801368" y="7461503"/>
-            <a:ext cx="4114800" cy="694944"/>
+            <a:off x="1801368" y="6675120"/>
+            <a:ext cx="3840480" cy="676656"/>
           </a:xfrm>
           <a:prstGeom prst="rect">
             <a:avLst/>
@@ -7012,14 +6918,14 @@
       </p:sp>
       <p:cxnSp>
         <p:nvCxnSpPr>
-          <p:cNvPr id="225" name="Разделитель"/>
+          <p:cNvPr id="222" name="Разделитель"/>
           <p:cNvCxnSpPr/>
           <p:nvPr/>
         </p:nvCxnSpPr>
         <p:spPr>
           <a:xfrm>
-            <a:off x="1069848" y="8156447"/>
-            <a:ext cx="4846320" cy="0"/>
+            <a:off x="1069848" y="7351776"/>
+            <a:ext cx="4572000" cy="0"/>
           </a:xfrm>
           <a:prstGeom prst="line">
             <a:avLst/>
@@ -7033,43 +6939,70 @@
       </p:cxnSp>
       <p:sp>
         <p:nvSpPr>
-          <p:cNvPr id="226" name="Стрелка к анализу среды"/>
+          <p:cNvPr id="223" name="Итог диагностики"/>
           <p:cNvSpPr/>
           <p:nvPr/>
         </p:nvSpPr>
         <p:spPr>
           <a:xfrm>
-            <a:off x="6126480" y="5468111"/>
-            <a:ext cx="502920" cy="512064"/>
-          </a:xfrm>
-          <a:prstGeom prst="rightArrow">
-            <a:avLst/>
+            <a:off x="1069848" y="7488936"/>
+            <a:ext cx="4572000" cy="1234439"/>
+          </a:xfrm>
+          <a:prstGeom prst="roundRect">
+            <a:avLst>
+              <a:gd name="adj" fmla="val 8000"/>
+            </a:avLst>
           </a:prstGeom>
           <a:solidFill>
-            <a:srgbClr val="FFCC00"/>
+            <a:srgbClr val="FFF3CC"/>
           </a:solidFill>
           <a:ln>
             <a:noFill/>
           </a:ln>
         </p:spPr>
         <p:txBody>
-          <a:bodyPr rtlCol="0" anchor="ctr"/>
+          <a:bodyPr rtlCol="0" anchor="ctr" wrap="square" lIns="228600" rIns="228600" tIns="0" bIns="0"/>
           <a:lstStyle/>
           <a:p>
-            <a:pPr algn="ctr"/>
+            <a:pPr algn="l"/>
+            <a:r>
+              <a:rPr sz="1400" b="1">
+                <a:solidFill>
+                  <a:srgbClr val="062D3F"/>
+                </a:solidFill>
+                <a:latin typeface="Circe Bold"/>
+              </a:rPr>
+              <a:t>ИТОГ</a:t>
+            </a:r>
+          </a:p>
+          <a:p>
+            <a:pPr algn="l">
+              <a:spcBef>
+                <a:spcPts val="400"/>
+              </a:spcBef>
+            </a:pPr>
+            <a:r>
+              <a:rPr sz="1500" b="1">
+                <a:solidFill>
+                  <a:srgbClr val="062D3F"/>
+                </a:solidFill>
+                <a:latin typeface="Circe Bold"/>
+              </a:rPr>
+              <a:t>Тип сельской территории, потенциалы, проблемы и ограничения</a:t>
+            </a:r>
           </a:p>
         </p:txBody>
       </p:sp>
       <p:sp>
         <p:nvSpPr>
-          <p:cNvPr id="227" name="Шапка анализа"/>
+          <p:cNvPr id="224" name="Шапка стратегического анализа"/>
           <p:cNvSpPr/>
           <p:nvPr/>
         </p:nvSpPr>
         <p:spPr>
           <a:xfrm>
-            <a:off x="6812280" y="2331720"/>
-            <a:ext cx="3108960" cy="502920"/>
+            <a:off x="6400800" y="2331720"/>
+            <a:ext cx="11548872" cy="502920"/>
           </a:xfrm>
           <a:prstGeom prst="rect">
             <a:avLst/>
@@ -7093,21 +7026,21 @@
                 </a:solidFill>
                 <a:latin typeface="Circe Bold"/>
               </a:rPr>
-              <a:t>АНАЛИЗ СРЕДЫ</a:t>
+              <a:t>СТРАТЕГИЧЕСКИЙ АНАЛИЗ</a:t>
             </a:r>
           </a:p>
         </p:txBody>
       </p:sp>
       <p:sp>
         <p:nvSpPr>
-          <p:cNvPr id="228" name="PEST"/>
+          <p:cNvPr id="225" name="PEST"/>
           <p:cNvSpPr/>
           <p:nvPr/>
         </p:nvSpPr>
         <p:spPr>
           <a:xfrm>
-            <a:off x="6812280" y="3291839"/>
-            <a:ext cx="3108960" cy="2331720"/>
+            <a:off x="6400800" y="3291839"/>
+            <a:ext cx="3200400" cy="2578608"/>
           </a:xfrm>
           <a:prstGeom prst="roundRect">
             <a:avLst>
@@ -7127,7 +7060,7 @@
           <a:p>
             <a:pPr algn="l"/>
             <a:r>
-              <a:rPr sz="3000" b="1">
+              <a:rPr sz="2800" b="1">
                 <a:solidFill>
                   <a:srgbClr val="062D3F"/>
                 </a:solidFill>
@@ -7139,31 +7072,31 @@
           <a:p>
             <a:pPr algn="l">
               <a:spcBef>
-                <a:spcPts val="800"/>
+                <a:spcPts val="600"/>
               </a:spcBef>
             </a:pPr>
             <a:r>
-              <a:rPr sz="1500" b="0">
+              <a:rPr sz="1400" b="0">
                 <a:solidFill>
                   <a:srgbClr val="062D3F"/>
                 </a:solidFill>
                 <a:latin typeface="Circe"/>
               </a:rPr>
-              <a:t>Политические, экономические, социальные и технологические факторы внешней среды</a:t>
+              <a:t>Политико-правовые, экономические, социокультурные и технологические факторы. Из них выводятся возможности и угрозы</a:t>
             </a:r>
           </a:p>
         </p:txBody>
       </p:sp>
       <p:sp>
         <p:nvSpPr>
-          <p:cNvPr id="229" name="SWOT"/>
+          <p:cNvPr id="226" name="Внутренние факторы"/>
           <p:cNvSpPr/>
           <p:nvPr/>
         </p:nvSpPr>
         <p:spPr>
           <a:xfrm>
-            <a:off x="6812280" y="6263640"/>
-            <a:ext cx="3108960" cy="2331720"/>
+            <a:off x="6400800" y="6144768"/>
+            <a:ext cx="3200400" cy="2578608"/>
           </a:xfrm>
           <a:prstGeom prst="roundRect">
             <a:avLst>
@@ -7183,72 +7116,43 @@
           <a:p>
             <a:pPr algn="l"/>
             <a:r>
-              <a:rPr sz="3000" b="1">
+              <a:rPr sz="2000" b="1">
                 <a:solidFill>
                   <a:srgbClr val="062D3F"/>
                 </a:solidFill>
                 <a:latin typeface="Circe Bold"/>
               </a:rPr>
-              <a:t>SWOT</a:t>
+              <a:t>ВНУТРЕННИЕ ФАКТОРЫ</a:t>
             </a:r>
           </a:p>
           <a:p>
             <a:pPr algn="l">
               <a:spcBef>
-                <a:spcPts val="800"/>
+                <a:spcPts val="600"/>
               </a:spcBef>
             </a:pPr>
             <a:r>
-              <a:rPr sz="1500" b="0">
+              <a:rPr sz="1400" b="0">
                 <a:solidFill>
                   <a:srgbClr val="062D3F"/>
                 </a:solidFill>
                 <a:latin typeface="Circe"/>
               </a:rPr>
-              <a:t>Сильные и слабые стороны территории, внешние возможности и угрозы</a:t>
+              <a:t>Что есть у самой территории. Из итогов диагностики выводятся сильные и слабые стороны</a:t>
             </a:r>
           </a:p>
         </p:txBody>
       </p:sp>
       <p:sp>
         <p:nvSpPr>
-          <p:cNvPr id="230" name="Стрелка к SWOT"/>
+          <p:cNvPr id="227" name="Стрелка к внутренним факторам"/>
           <p:cNvSpPr/>
           <p:nvPr/>
         </p:nvSpPr>
         <p:spPr>
           <a:xfrm>
-            <a:off x="8110728" y="5714999"/>
-            <a:ext cx="512064" cy="502920"/>
-          </a:xfrm>
-          <a:prstGeom prst="downArrow">
-            <a:avLst/>
-          </a:prstGeom>
-          <a:solidFill>
-            <a:srgbClr val="FFCC00"/>
-          </a:solidFill>
-          <a:ln>
-            <a:noFill/>
-          </a:ln>
-        </p:spPr>
-        <p:txBody>
-          <a:bodyPr rtlCol="0" anchor="ctr"/>
-          <a:lstStyle/>
-          <a:p>
-            <a:pPr algn="ctr"/>
-          </a:p>
-        </p:txBody>
-      </p:sp>
-      <p:sp>
-        <p:nvSpPr>
-          <p:cNvPr id="231" name="Стрелка к дереву"/>
-          <p:cNvSpPr/>
-          <p:nvPr/>
-        </p:nvSpPr>
-        <p:spPr>
-          <a:xfrm>
-            <a:off x="10012680" y="5468111"/>
-            <a:ext cx="502920" cy="512064"/>
+            <a:off x="5806440" y="7196327"/>
+            <a:ext cx="457200" cy="475488"/>
           </a:xfrm>
           <a:prstGeom prst="rightArrow">
             <a:avLst/>
@@ -7268,58 +7172,104 @@
           </a:p>
         </p:txBody>
       </p:sp>
+      <p:cxnSp>
+        <p:nvCxnSpPr>
+          <p:cNvPr id="228" name="Связь PEST"/>
+          <p:cNvCxnSpPr/>
+          <p:nvPr/>
+        </p:nvCxnSpPr>
+        <p:spPr>
+          <a:xfrm>
+            <a:off x="9601200" y="4581144"/>
+            <a:ext cx="365760" cy="0"/>
+          </a:xfrm>
+          <a:prstGeom prst="line">
+            <a:avLst/>
+          </a:prstGeom>
+          <a:ln w="25400">
+            <a:solidFill>
+              <a:srgbClr val="062D3F"/>
+            </a:solidFill>
+          </a:ln>
+        </p:spPr>
+      </p:cxnSp>
+      <p:cxnSp>
+        <p:nvCxnSpPr>
+          <p:cNvPr id="229" name="Связь внутренних"/>
+          <p:cNvCxnSpPr/>
+          <p:nvPr/>
+        </p:nvCxnSpPr>
+        <p:spPr>
+          <a:xfrm>
+            <a:off x="9601200" y="7434071"/>
+            <a:ext cx="365760" cy="0"/>
+          </a:xfrm>
+          <a:prstGeom prst="line">
+            <a:avLst/>
+          </a:prstGeom>
+          <a:ln w="25400">
+            <a:solidFill>
+              <a:srgbClr val="062D3F"/>
+            </a:solidFill>
+          </a:ln>
+        </p:spPr>
+      </p:cxnSp>
+      <p:cxnSp>
+        <p:nvCxnSpPr>
+          <p:cNvPr id="230" name="Связь"/>
+          <p:cNvCxnSpPr/>
+          <p:nvPr/>
+        </p:nvCxnSpPr>
+        <p:spPr>
+          <a:xfrm>
+            <a:off x="9966960" y="4581144"/>
+            <a:ext cx="0" cy="2852927"/>
+          </a:xfrm>
+          <a:prstGeom prst="line">
+            <a:avLst/>
+          </a:prstGeom>
+          <a:ln w="25400">
+            <a:solidFill>
+              <a:srgbClr val="062D3F"/>
+            </a:solidFill>
+          </a:ln>
+        </p:spPr>
+      </p:cxnSp>
+      <p:cxnSp>
+        <p:nvCxnSpPr>
+          <p:cNvPr id="231" name="Связь к SWOT"/>
+          <p:cNvCxnSpPr/>
+          <p:nvPr/>
+        </p:nvCxnSpPr>
+        <p:spPr>
+          <a:xfrm>
+            <a:off x="9966960" y="6007607"/>
+            <a:ext cx="411480" cy="0"/>
+          </a:xfrm>
+          <a:prstGeom prst="line">
+            <a:avLst/>
+          </a:prstGeom>
+          <a:ln w="25400">
+            <a:solidFill>
+              <a:srgbClr val="062D3F"/>
+            </a:solidFill>
+          </a:ln>
+        </p:spPr>
+      </p:cxnSp>
       <p:sp>
         <p:nvSpPr>
-          <p:cNvPr id="232" name="Шапка дерева"/>
+          <p:cNvPr id="232" name="SWOT"/>
           <p:cNvSpPr/>
           <p:nvPr/>
         </p:nvSpPr>
         <p:spPr>
           <a:xfrm>
-            <a:off x="10744200" y="2331720"/>
-            <a:ext cx="7205471" cy="502920"/>
-          </a:xfrm>
-          <a:prstGeom prst="rect">
-            <a:avLst/>
-          </a:prstGeom>
-          <a:solidFill>
-            <a:srgbClr val="062D3F"/>
-          </a:solidFill>
-          <a:ln>
-            <a:noFill/>
-          </a:ln>
-        </p:spPr>
-        <p:txBody>
-          <a:bodyPr rtlCol="0" anchor="ctr" wrap="square" lIns="182880" rIns="182880" tIns="0" bIns="0"/>
-          <a:lstStyle/>
-          <a:p>
-            <a:pPr algn="l"/>
-            <a:r>
-              <a:rPr sz="1600" b="1">
-                <a:solidFill>
-                  <a:srgbClr val="FFFFFF"/>
-                </a:solidFill>
-                <a:latin typeface="Circe Bold"/>
-              </a:rPr>
-              <a:t>ДЕРЕВО ВОЗМОЖНОСТЕЙ</a:t>
-            </a:r>
-          </a:p>
-        </p:txBody>
-      </p:sp>
-      <p:sp>
-        <p:nvSpPr>
-          <p:cNvPr id="233" name="Выбор стратегии"/>
-          <p:cNvSpPr/>
-          <p:nvPr/>
-        </p:nvSpPr>
-        <p:spPr>
-          <a:xfrm>
-            <a:off x="10744200" y="5175503"/>
-            <a:ext cx="1737360" cy="1097280"/>
+            <a:off x="10378440" y="5276088"/>
+            <a:ext cx="1920240" cy="1463040"/>
           </a:xfrm>
           <a:prstGeom prst="roundRect">
             <a:avLst>
-              <a:gd name="adj" fmla="val 15000"/>
+              <a:gd name="adj" fmla="val 12000"/>
             </a:avLst>
           </a:prstGeom>
           <a:solidFill>
@@ -7330,31 +7280,47 @@
           </a:ln>
         </p:spPr>
         <p:txBody>
-          <a:bodyPr rtlCol="0" anchor="ctr" wrap="square" tIns="0" bIns="0"/>
+          <a:bodyPr rtlCol="0" anchor="ctr" wrap="square" lIns="109728" rIns="109728" tIns="0" bIns="0"/>
           <a:lstStyle/>
           <a:p>
             <a:pPr algn="ctr"/>
             <a:r>
-              <a:rPr sz="1600" b="1">
+              <a:rPr sz="2600" b="1">
                 <a:solidFill>
                   <a:srgbClr val="062D3F"/>
                 </a:solidFill>
                 <a:latin typeface="Circe Bold"/>
               </a:rPr>
-              <a:t>Выбор стратегии</a:t>
+              <a:t>SWOT</a:t>
+            </a:r>
+          </a:p>
+          <a:p>
+            <a:pPr algn="ctr">
+              <a:spcBef>
+                <a:spcPts val="400"/>
+              </a:spcBef>
+            </a:pPr>
+            <a:r>
+              <a:rPr sz="1300" b="0">
+                <a:solidFill>
+                  <a:srgbClr val="062D3F"/>
+                </a:solidFill>
+                <a:latin typeface="Circe"/>
+              </a:rPr>
+              <a:t>сводит внешнее и внутреннее</a:t>
             </a:r>
           </a:p>
         </p:txBody>
       </p:sp>
       <p:cxnSp>
         <p:nvCxnSpPr>
-          <p:cNvPr id="234" name="Ствол"/>
+          <p:cNvPr id="233" name="Ствол"/>
           <p:cNvCxnSpPr/>
           <p:nvPr/>
         </p:nvCxnSpPr>
         <p:spPr>
           <a:xfrm>
-            <a:off x="12481560" y="5724143"/>
+            <a:off x="12298680" y="6007607"/>
             <a:ext cx="320040" cy="0"/>
           </a:xfrm>
           <a:prstGeom prst="line">
@@ -7369,13 +7335,13 @@
       </p:cxnSp>
       <p:cxnSp>
         <p:nvCxnSpPr>
-          <p:cNvPr id="235" name="Ствол"/>
+          <p:cNvPr id="234" name="Ствол"/>
           <p:cNvCxnSpPr/>
           <p:nvPr/>
         </p:nvCxnSpPr>
         <p:spPr>
           <a:xfrm>
-            <a:off x="12801600" y="3909059"/>
+            <a:off x="12618720" y="3909059"/>
             <a:ext cx="0" cy="4197097"/>
           </a:xfrm>
           <a:prstGeom prst="line">
@@ -7390,14 +7356,14 @@
       </p:cxnSp>
       <p:cxnSp>
         <p:nvCxnSpPr>
-          <p:cNvPr id="236" name="Ветвь 1"/>
+          <p:cNvPr id="235" name="Ветвь 1"/>
           <p:cNvCxnSpPr/>
           <p:nvPr/>
         </p:nvCxnSpPr>
         <p:spPr>
           <a:xfrm>
-            <a:off x="12801600" y="3909059"/>
-            <a:ext cx="365760" cy="0"/>
+            <a:off x="12618720" y="3909059"/>
+            <a:ext cx="320040" cy="0"/>
           </a:xfrm>
           <a:prstGeom prst="line">
             <a:avLst/>
@@ -7411,14 +7377,14 @@
       </p:cxnSp>
       <p:sp>
         <p:nvSpPr>
-          <p:cNvPr id="237" name="Стратегия Рост"/>
+          <p:cNvPr id="236" name="Стратегия Рост"/>
           <p:cNvSpPr/>
           <p:nvPr/>
         </p:nvSpPr>
         <p:spPr>
           <a:xfrm>
-            <a:off x="13167360" y="3291839"/>
-            <a:ext cx="4782311" cy="1234440"/>
+            <a:off x="12938760" y="3291839"/>
+            <a:ext cx="5010911" cy="1234439"/>
           </a:xfrm>
           <a:prstGeom prst="roundRect">
             <a:avLst>
@@ -7460,21 +7426,21 @@
                 </a:solidFill>
                 <a:latin typeface="Circe"/>
               </a:rPr>
-              <a:t>Развитие территорий с высоким потенциалом, пригородных и опорных, привлечение жителей и инвестиций, новое жильё и рабочие места</a:t>
+              <a:t>Сильных сторон и возможностей больше. Наращивать то, что уже получается</a:t>
             </a:r>
           </a:p>
         </p:txBody>
       </p:sp>
       <p:sp>
         <p:nvSpPr>
-          <p:cNvPr id="238" name="Акцент"/>
+          <p:cNvPr id="237" name="Акцент"/>
           <p:cNvSpPr/>
           <p:nvPr/>
         </p:nvSpPr>
         <p:spPr>
           <a:xfrm>
-            <a:off x="13167360" y="3428999"/>
-            <a:ext cx="82296" cy="960120"/>
+            <a:off x="12938760" y="3428999"/>
+            <a:ext cx="82296" cy="960119"/>
           </a:xfrm>
           <a:prstGeom prst="rect">
             <a:avLst/>
@@ -7494,6 +7460,41 @@
           </a:p>
         </p:txBody>
       </p:sp>
+      <p:sp>
+        <p:nvSpPr>
+          <p:cNvPr id="238" name="Сочетание S + O"/>
+          <p:cNvSpPr txBox="1"/>
+          <p:nvPr/>
+        </p:nvSpPr>
+        <p:spPr>
+          <a:xfrm>
+            <a:off x="16760951" y="3401568"/>
+            <a:ext cx="1005840" cy="320040"/>
+          </a:xfrm>
+          <a:prstGeom prst="rect">
+            <a:avLst/>
+          </a:prstGeom>
+          <a:noFill/>
+        </p:spPr>
+        <p:txBody>
+          <a:bodyPr wrap="square" anchor="ctr" lIns="0" rIns="0" tIns="0" bIns="0">
+            <a:spAutoFit/>
+          </a:bodyPr>
+          <a:lstStyle/>
+          <a:p>
+            <a:pPr algn="r"/>
+            <a:r>
+              <a:rPr sz="1400" b="1">
+                <a:solidFill>
+                  <a:srgbClr val="5E6B73"/>
+                </a:solidFill>
+                <a:latin typeface="Circe Bold"/>
+              </a:rPr>
+              <a:t>S + O</a:t>
+            </a:r>
+          </a:p>
+        </p:txBody>
+      </p:sp>
       <p:cxnSp>
         <p:nvCxnSpPr>
           <p:cNvPr id="239" name="Ветвь 2"/>
@@ -7502,8 +7503,8 @@
         </p:nvCxnSpPr>
         <p:spPr>
           <a:xfrm>
-            <a:off x="12801600" y="5308092"/>
-            <a:ext cx="365760" cy="0"/>
+            <a:off x="12618720" y="5308091"/>
+            <a:ext cx="320040" cy="0"/>
           </a:xfrm>
           <a:prstGeom prst="line">
             <a:avLst/>
@@ -7517,14 +7518,14 @@
       </p:cxnSp>
       <p:sp>
         <p:nvSpPr>
-          <p:cNvPr id="240" name="Стратегия Укрепление"/>
+          <p:cNvPr id="240" name="Стратегия Защита"/>
           <p:cNvSpPr/>
           <p:nvPr/>
         </p:nvSpPr>
         <p:spPr>
           <a:xfrm>
-            <a:off x="13167360" y="4690872"/>
-            <a:ext cx="4782311" cy="1234440"/>
+            <a:off x="12938760" y="4690871"/>
+            <a:ext cx="5010911" cy="1234439"/>
           </a:xfrm>
           <a:prstGeom prst="roundRect">
             <a:avLst>
@@ -7550,7 +7551,7 @@
                 </a:solidFill>
                 <a:latin typeface="Circe Bold"/>
               </a:rPr>
-              <a:t>УКРЕПЛЕНИЕ</a:t>
+              <a:t>ЗАЩИТА</a:t>
             </a:r>
           </a:p>
           <a:p>
@@ -7566,7 +7567,7 @@
                 </a:solidFill>
                 <a:latin typeface="Circe"/>
               </a:rPr>
-              <a:t>Поддержка устойчивых территорий, модернизация инфраструктуры, диверсификация экономики, закрепление населения</a:t>
+              <a:t>Сильные стороны есть, но внешняя среда угрожает. Опереться на них, чтобы удержать позиции</a:t>
             </a:r>
           </a:p>
         </p:txBody>
@@ -7579,8 +7580,8 @@
         </p:nvSpPr>
         <p:spPr>
           <a:xfrm>
-            <a:off x="13167360" y="4828032"/>
-            <a:ext cx="82296" cy="960120"/>
+            <a:off x="12938760" y="4828031"/>
+            <a:ext cx="82296" cy="960119"/>
           </a:xfrm>
           <a:prstGeom prst="rect">
             <a:avLst/>
@@ -7600,16 +7601,51 @@
           </a:p>
         </p:txBody>
       </p:sp>
+      <p:sp>
+        <p:nvSpPr>
+          <p:cNvPr id="242" name="Сочетание S + T"/>
+          <p:cNvSpPr txBox="1"/>
+          <p:nvPr/>
+        </p:nvSpPr>
+        <p:spPr>
+          <a:xfrm>
+            <a:off x="16760951" y="4800599"/>
+            <a:ext cx="1005840" cy="320040"/>
+          </a:xfrm>
+          <a:prstGeom prst="rect">
+            <a:avLst/>
+          </a:prstGeom>
+          <a:noFill/>
+        </p:spPr>
+        <p:txBody>
+          <a:bodyPr wrap="square" anchor="ctr" lIns="0" rIns="0" tIns="0" bIns="0">
+            <a:spAutoFit/>
+          </a:bodyPr>
+          <a:lstStyle/>
+          <a:p>
+            <a:pPr algn="r"/>
+            <a:r>
+              <a:rPr sz="1400" b="1">
+                <a:solidFill>
+                  <a:srgbClr val="5E6B73"/>
+                </a:solidFill>
+                <a:latin typeface="Circe Bold"/>
+              </a:rPr>
+              <a:t>S + T</a:t>
+            </a:r>
+          </a:p>
+        </p:txBody>
+      </p:sp>
       <p:cxnSp>
         <p:nvCxnSpPr>
-          <p:cNvPr id="242" name="Ветвь 3"/>
+          <p:cNvPr id="243" name="Ветвь 3"/>
           <p:cNvCxnSpPr/>
           <p:nvPr/>
         </p:nvCxnSpPr>
         <p:spPr>
           <a:xfrm>
-            <a:off x="12801600" y="6707124"/>
-            <a:ext cx="365760" cy="0"/>
+            <a:off x="12618720" y="6707123"/>
+            <a:ext cx="320040" cy="0"/>
           </a:xfrm>
           <a:prstGeom prst="line">
             <a:avLst/>
@@ -7623,14 +7659,14 @@
       </p:cxnSp>
       <p:sp>
         <p:nvSpPr>
-          <p:cNvPr id="243" name="Стратегия Сдерживание"/>
+          <p:cNvPr id="244" name="Стратегия Укрепление"/>
           <p:cNvSpPr/>
           <p:nvPr/>
         </p:nvSpPr>
         <p:spPr>
           <a:xfrm>
-            <a:off x="13167360" y="6089904"/>
-            <a:ext cx="4782311" cy="1234440"/>
+            <a:off x="12938760" y="6089903"/>
+            <a:ext cx="5010911" cy="1234439"/>
           </a:xfrm>
           <a:prstGeom prst="roundRect">
             <a:avLst>
@@ -7656,7 +7692,7 @@
                 </a:solidFill>
                 <a:latin typeface="Circe Bold"/>
               </a:rPr>
-              <a:t>СДЕРЖИВАНИЕ</a:t>
+              <a:t>УКРЕПЛЕНИЕ</a:t>
             </a:r>
           </a:p>
           <a:p>
@@ -7672,21 +7708,21 @@
                 </a:solidFill>
                 <a:latin typeface="Circe"/>
               </a:rPr>
-              <a:t>Замедление депопуляции и старения, сохранение сети услуг, удержание кадров и хозяйств</a:t>
+              <a:t>Возможности есть, но мешают слабые стороны. Использовать внешние ресурсы, чтобы их устранить</a:t>
             </a:r>
           </a:p>
         </p:txBody>
       </p:sp>
       <p:sp>
         <p:nvSpPr>
-          <p:cNvPr id="244" name="Акцент"/>
+          <p:cNvPr id="245" name="Акцент"/>
           <p:cNvSpPr/>
           <p:nvPr/>
         </p:nvSpPr>
         <p:spPr>
           <a:xfrm>
-            <a:off x="13167360" y="6227064"/>
-            <a:ext cx="82296" cy="960120"/>
+            <a:off x="12938760" y="6227064"/>
+            <a:ext cx="82296" cy="960119"/>
           </a:xfrm>
           <a:prstGeom prst="rect">
             <a:avLst/>
@@ -7706,16 +7742,51 @@
           </a:p>
         </p:txBody>
       </p:sp>
+      <p:sp>
+        <p:nvSpPr>
+          <p:cNvPr id="246" name="Сочетание W + O"/>
+          <p:cNvSpPr txBox="1"/>
+          <p:nvPr/>
+        </p:nvSpPr>
+        <p:spPr>
+          <a:xfrm>
+            <a:off x="16760951" y="6199631"/>
+            <a:ext cx="1005840" cy="320040"/>
+          </a:xfrm>
+          <a:prstGeom prst="rect">
+            <a:avLst/>
+          </a:prstGeom>
+          <a:noFill/>
+        </p:spPr>
+        <p:txBody>
+          <a:bodyPr wrap="square" anchor="ctr" lIns="0" rIns="0" tIns="0" bIns="0">
+            <a:spAutoFit/>
+          </a:bodyPr>
+          <a:lstStyle/>
+          <a:p>
+            <a:pPr algn="r"/>
+            <a:r>
+              <a:rPr sz="1400" b="1">
+                <a:solidFill>
+                  <a:srgbClr val="5E6B73"/>
+                </a:solidFill>
+                <a:latin typeface="Circe Bold"/>
+              </a:rPr>
+              <a:t>W + O</a:t>
+            </a:r>
+          </a:p>
+        </p:txBody>
+      </p:sp>
       <p:cxnSp>
         <p:nvCxnSpPr>
-          <p:cNvPr id="245" name="Ветвь 4"/>
+          <p:cNvPr id="247" name="Ветвь 4"/>
           <p:cNvCxnSpPr/>
           <p:nvPr/>
         </p:nvCxnSpPr>
         <p:spPr>
           <a:xfrm>
-            <a:off x="12801600" y="8106156"/>
-            <a:ext cx="365760" cy="0"/>
+            <a:off x="12618720" y="8106156"/>
+            <a:ext cx="320040" cy="0"/>
           </a:xfrm>
           <a:prstGeom prst="line">
             <a:avLst/>
@@ -7729,14 +7800,14 @@
       </p:cxnSp>
       <p:sp>
         <p:nvSpPr>
-          <p:cNvPr id="246" name="Стратегия Сжатие"/>
+          <p:cNvPr id="248" name="Стратегия Сжатие"/>
           <p:cNvSpPr/>
           <p:nvPr/>
         </p:nvSpPr>
         <p:spPr>
           <a:xfrm>
-            <a:off x="13167360" y="7488936"/>
-            <a:ext cx="4782311" cy="1234440"/>
+            <a:off x="12938760" y="7488936"/>
+            <a:ext cx="5010911" cy="1234439"/>
           </a:xfrm>
           <a:prstGeom prst="roundRect">
             <a:avLst>
@@ -7778,21 +7849,21 @@
                 </a:solidFill>
                 <a:latin typeface="Circe"/>
               </a:rPr>
-              <a:t>Управляемое сокращение сети расселения, концентрация услуг в опорных пунктах, вывод неэффективной инфраструктуры</a:t>
+              <a:t>Преобладают слабости и угрозы. Сохранять главное и сокращать потери</a:t>
             </a:r>
           </a:p>
         </p:txBody>
       </p:sp>
       <p:sp>
         <p:nvSpPr>
-          <p:cNvPr id="247" name="Акцент"/>
+          <p:cNvPr id="249" name="Акцент"/>
           <p:cNvSpPr/>
           <p:nvPr/>
         </p:nvSpPr>
         <p:spPr>
           <a:xfrm>
-            <a:off x="13167360" y="7626096"/>
-            <a:ext cx="82296" cy="960120"/>
+            <a:off x="12938760" y="7626096"/>
+            <a:ext cx="82296" cy="960119"/>
           </a:xfrm>
           <a:prstGeom prst="rect">
             <a:avLst/>
@@ -7814,7 +7885,42 @@
       </p:sp>
       <p:sp>
         <p:nvSpPr>
-          <p:cNvPr id="248" name="Решения"/>
+          <p:cNvPr id="250" name="Сочетание W + T"/>
+          <p:cNvSpPr txBox="1"/>
+          <p:nvPr/>
+        </p:nvSpPr>
+        <p:spPr>
+          <a:xfrm>
+            <a:off x="16760951" y="7598663"/>
+            <a:ext cx="1005840" cy="320040"/>
+          </a:xfrm>
+          <a:prstGeom prst="rect">
+            <a:avLst/>
+          </a:prstGeom>
+          <a:noFill/>
+        </p:spPr>
+        <p:txBody>
+          <a:bodyPr wrap="square" anchor="ctr" lIns="0" rIns="0" tIns="0" bIns="0">
+            <a:spAutoFit/>
+          </a:bodyPr>
+          <a:lstStyle/>
+          <a:p>
+            <a:pPr algn="r"/>
+            <a:r>
+              <a:rPr sz="1400" b="1">
+                <a:solidFill>
+                  <a:srgbClr val="5E6B73"/>
+                </a:solidFill>
+                <a:latin typeface="Circe Bold"/>
+              </a:rPr>
+              <a:t>W + T</a:t>
+            </a:r>
+          </a:p>
+        </p:txBody>
+      </p:sp>
+      <p:sp>
+        <p:nvSpPr>
+          <p:cNvPr id="251" name="Решения"/>
           <p:cNvSpPr/>
           <p:nvPr/>
         </p:nvSpPr>
@@ -7854,7 +7960,7 @@
       </p:sp>
       <p:sp>
         <p:nvSpPr>
-          <p:cNvPr id="249" name="Решения текст"/>
+          <p:cNvPr id="252" name="Решения текст"/>
           <p:cNvSpPr txBox="1"/>
           <p:nvPr/>
         </p:nvSpPr>
@@ -7882,7 +7988,7 @@
                 </a:solidFill>
                 <a:latin typeface="Circe"/>
               </a:rPr>
-              <a:t>Приоритеты, проекты и меры, размещение опорных пунктов, закрепление в СТП, генплане и программах. Мониторинг целевых показателей и повторная диагностика</a:t>
+              <a:t>Цели и приоритеты, проекты и меры, размещение опорных пунктов, закрепление в СТП, генплане и программах. Мониторинг целевых показателей и повторная диагностика</a:t>
             </a:r>
           </a:p>
         </p:txBody>

</xml_diff>

<commit_message>
Scheme: SWOT under PEST, drop internal factors, separate Strategy header
Co-Authored-By: Claude Sonnet 5.5 <noreply@anthropic.com>
Claude-Session: https://claude.ai/code/session_01PfagTkBBfn3ShTm5bX9M45
</commit_message>
<xml_diff>
--- a/slide_shema_diagnostika_strategii.pptx
+++ b/slide_shema_diagnostika_strategii.pptx
@@ -430,7 +430,7 @@
           <a:lstStyle/>
           <a:p>
             <a:r>
-              <a:t>Схема построена по лекции про SWOT и PEST (слайды 3, 10 и 11). Названия и описания четырёх стратегий (рост, защита, укрепление, сжатие) взяты со слайда 11 лекции. Блоки диагностики соответствуют разделам основной лекции, тип территории вынесен в итог диагностики. Внутренние факторы (S и W) выводятся из итогов диагностики, внешние (O и T) из PEST.</a:t>
+              <a:t>Схема построена по лекции про SWOT и PEST (слайды 3, 10 и 11). Названия и описания четырёх стратегий (рост, защита, укрепление, сжатие) взяты со слайда 11 лекции. Блоки диагностики соответствуют разделам основной лекции, тип территории вынесен в итог диагностики. Сильные и слабые стороны (S и W) выводятся из итогов диагностики, возможности и угрозы (O и T) из PEST.</a:t>
             </a:r>
           </a:p>
         </p:txBody>
@@ -7002,7 +7002,7 @@
         <p:spPr>
           <a:xfrm>
             <a:off x="6400800" y="2331720"/>
-            <a:ext cx="11548872" cy="502920"/>
+            <a:ext cx="4206240" cy="502920"/>
           </a:xfrm>
           <a:prstGeom prst="rect">
             <a:avLst/>
@@ -7040,7 +7040,7 @@
         <p:spPr>
           <a:xfrm>
             <a:off x="6400800" y="3291839"/>
-            <a:ext cx="3200400" cy="2578608"/>
+            <a:ext cx="4206240" cy="2372868"/>
           </a:xfrm>
           <a:prstGeom prst="roundRect">
             <a:avLst>
@@ -7055,7 +7055,7 @@
           </a:ln>
         </p:spPr>
         <p:txBody>
-          <a:bodyPr rtlCol="0" anchor="ctr" wrap="square" lIns="228600" rIns="228600" tIns="0" bIns="0"/>
+          <a:bodyPr rtlCol="0" anchor="ctr" wrap="square" lIns="274320" rIns="274320" tIns="0" bIns="0"/>
           <a:lstStyle/>
           <a:p>
             <a:pPr algn="l"/>
@@ -7076,7 +7076,7 @@
               </a:spcBef>
             </a:pPr>
             <a:r>
-              <a:rPr sz="1400" b="0">
+              <a:rPr sz="1500" b="0">
                 <a:solidFill>
                   <a:srgbClr val="062D3F"/>
                 </a:solidFill>
@@ -7089,14 +7089,43 @@
       </p:sp>
       <p:sp>
         <p:nvSpPr>
-          <p:cNvPr id="226" name="Внутренние факторы"/>
+          <p:cNvPr id="226" name="Стрелка к SWOT"/>
           <p:cNvSpPr/>
           <p:nvPr/>
         </p:nvSpPr>
         <p:spPr>
           <a:xfrm>
-            <a:off x="6400800" y="6144768"/>
-            <a:ext cx="3200400" cy="2578608"/>
+            <a:off x="8247888" y="5756147"/>
+            <a:ext cx="512064" cy="502920"/>
+          </a:xfrm>
+          <a:prstGeom prst="downArrow">
+            <a:avLst/>
+          </a:prstGeom>
+          <a:solidFill>
+            <a:srgbClr val="FFCC00"/>
+          </a:solidFill>
+          <a:ln>
+            <a:noFill/>
+          </a:ln>
+        </p:spPr>
+        <p:txBody>
+          <a:bodyPr rtlCol="0" anchor="ctr"/>
+          <a:lstStyle/>
+          <a:p>
+            <a:pPr algn="ctr"/>
+          </a:p>
+        </p:txBody>
+      </p:sp>
+      <p:sp>
+        <p:nvSpPr>
+          <p:cNvPr id="227" name="SWOT"/>
+          <p:cNvSpPr/>
+          <p:nvPr/>
+        </p:nvSpPr>
+        <p:spPr>
+          <a:xfrm>
+            <a:off x="6400800" y="6350507"/>
+            <a:ext cx="4206240" cy="2372868"/>
           </a:xfrm>
           <a:prstGeom prst="roundRect">
             <a:avLst>
@@ -7111,18 +7140,18 @@
           </a:ln>
         </p:spPr>
         <p:txBody>
-          <a:bodyPr rtlCol="0" anchor="ctr" wrap="square" lIns="228600" rIns="228600" tIns="0" bIns="0"/>
+          <a:bodyPr rtlCol="0" anchor="ctr" wrap="square" lIns="274320" rIns="274320" tIns="0" bIns="0"/>
           <a:lstStyle/>
           <a:p>
             <a:pPr algn="l"/>
             <a:r>
-              <a:rPr sz="2000" b="1">
+              <a:rPr sz="2800" b="1">
                 <a:solidFill>
                   <a:srgbClr val="062D3F"/>
                 </a:solidFill>
                 <a:latin typeface="Circe Bold"/>
               </a:rPr>
-              <a:t>ВНУТРЕННИЕ ФАКТОРЫ</a:t>
+              <a:t>SWOT</a:t>
             </a:r>
           </a:p>
           <a:p>
@@ -7132,26 +7161,26 @@
               </a:spcBef>
             </a:pPr>
             <a:r>
-              <a:rPr sz="1400" b="0">
+              <a:rPr sz="1500" b="0">
                 <a:solidFill>
                   <a:srgbClr val="062D3F"/>
                 </a:solidFill>
                 <a:latin typeface="Circe"/>
               </a:rPr>
-              <a:t>Что есть у самой территории. Из итогов диагностики выводятся сильные и слабые стороны</a:t>
+              <a:t>Сильные и слабые стороны территории из итогов диагностики сводятся с возможностями и угрозами из PEST</a:t>
             </a:r>
           </a:p>
         </p:txBody>
       </p:sp>
       <p:sp>
         <p:nvSpPr>
-          <p:cNvPr id="227" name="Стрелка к внутренним факторам"/>
+          <p:cNvPr id="228" name="Стрелка от диагностики к SWOT"/>
           <p:cNvSpPr/>
           <p:nvPr/>
         </p:nvSpPr>
         <p:spPr>
           <a:xfrm>
-            <a:off x="5806440" y="7196327"/>
+            <a:off x="5852160" y="7299198"/>
             <a:ext cx="457200" cy="475488"/>
           </a:xfrm>
           <a:prstGeom prst="rightArrow">
@@ -7172,16 +7201,54 @@
           </a:p>
         </p:txBody>
       </p:sp>
+      <p:sp>
+        <p:nvSpPr>
+          <p:cNvPr id="229" name="Шапка стратегии"/>
+          <p:cNvSpPr/>
+          <p:nvPr/>
+        </p:nvSpPr>
+        <p:spPr>
+          <a:xfrm>
+            <a:off x="11887200" y="2331720"/>
+            <a:ext cx="6062471" cy="502920"/>
+          </a:xfrm>
+          <a:prstGeom prst="rect">
+            <a:avLst/>
+          </a:prstGeom>
+          <a:solidFill>
+            <a:srgbClr val="062D3F"/>
+          </a:solidFill>
+          <a:ln>
+            <a:noFill/>
+          </a:ln>
+        </p:spPr>
+        <p:txBody>
+          <a:bodyPr rtlCol="0" anchor="ctr" wrap="square" lIns="182880" rIns="182880" tIns="0" bIns="0"/>
+          <a:lstStyle/>
+          <a:p>
+            <a:pPr algn="l"/>
+            <a:r>
+              <a:rPr sz="1600" b="1">
+                <a:solidFill>
+                  <a:srgbClr val="FFFFFF"/>
+                </a:solidFill>
+                <a:latin typeface="Circe Bold"/>
+              </a:rPr>
+              <a:t>СТРАТЕГИЯ</a:t>
+            </a:r>
+          </a:p>
+        </p:txBody>
+      </p:sp>
       <p:cxnSp>
         <p:nvCxnSpPr>
-          <p:cNvPr id="228" name="Связь PEST"/>
+          <p:cNvPr id="230" name="Ствол"/>
           <p:cNvCxnSpPr/>
           <p:nvPr/>
         </p:nvCxnSpPr>
         <p:spPr>
           <a:xfrm>
-            <a:off x="9601200" y="4581144"/>
-            <a:ext cx="365760" cy="0"/>
+            <a:off x="10607040" y="7536942"/>
+            <a:ext cx="822960" cy="0"/>
           </a:xfrm>
           <a:prstGeom prst="line">
             <a:avLst/>
@@ -7195,14 +7262,14 @@
       </p:cxnSp>
       <p:cxnSp>
         <p:nvCxnSpPr>
-          <p:cNvPr id="229" name="Связь внутренних"/>
+          <p:cNvPr id="231" name="Ствол"/>
           <p:cNvCxnSpPr/>
           <p:nvPr/>
         </p:nvCxnSpPr>
         <p:spPr>
           <a:xfrm>
-            <a:off x="9601200" y="7434071"/>
-            <a:ext cx="365760" cy="0"/>
+            <a:off x="11430000" y="3909059"/>
+            <a:ext cx="0" cy="4197097"/>
           </a:xfrm>
           <a:prstGeom prst="line">
             <a:avLst/>
@@ -7216,14 +7283,14 @@
       </p:cxnSp>
       <p:cxnSp>
         <p:nvCxnSpPr>
-          <p:cNvPr id="230" name="Связь"/>
+          <p:cNvPr id="232" name="Ветвь 1"/>
           <p:cNvCxnSpPr/>
           <p:nvPr/>
         </p:nvCxnSpPr>
         <p:spPr>
           <a:xfrm>
-            <a:off x="9966960" y="4581144"/>
-            <a:ext cx="0" cy="2852927"/>
+            <a:off x="11430000" y="3909059"/>
+            <a:ext cx="457200" cy="0"/>
           </a:xfrm>
           <a:prstGeom prst="line">
             <a:avLst/>
@@ -7235,156 +7302,16 @@
           </a:ln>
         </p:spPr>
       </p:cxnSp>
-      <p:cxnSp>
-        <p:nvCxnSpPr>
-          <p:cNvPr id="231" name="Связь к SWOT"/>
-          <p:cNvCxnSpPr/>
-          <p:nvPr/>
-        </p:nvCxnSpPr>
-        <p:spPr>
-          <a:xfrm>
-            <a:off x="9966960" y="6007607"/>
-            <a:ext cx="411480" cy="0"/>
-          </a:xfrm>
-          <a:prstGeom prst="line">
-            <a:avLst/>
-          </a:prstGeom>
-          <a:ln w="25400">
-            <a:solidFill>
-              <a:srgbClr val="062D3F"/>
-            </a:solidFill>
-          </a:ln>
-        </p:spPr>
-      </p:cxnSp>
-      <p:sp>
-        <p:nvSpPr>
-          <p:cNvPr id="232" name="SWOT"/>
+      <p:sp>
+        <p:nvSpPr>
+          <p:cNvPr id="233" name="Стратегия Рост"/>
           <p:cNvSpPr/>
           <p:nvPr/>
         </p:nvSpPr>
         <p:spPr>
           <a:xfrm>
-            <a:off x="10378440" y="5276088"/>
-            <a:ext cx="1920240" cy="1463040"/>
-          </a:xfrm>
-          <a:prstGeom prst="roundRect">
-            <a:avLst>
-              <a:gd name="adj" fmla="val 12000"/>
-            </a:avLst>
-          </a:prstGeom>
-          <a:solidFill>
-            <a:srgbClr val="FFCC00"/>
-          </a:solidFill>
-          <a:ln>
-            <a:noFill/>
-          </a:ln>
-        </p:spPr>
-        <p:txBody>
-          <a:bodyPr rtlCol="0" anchor="ctr" wrap="square" lIns="109728" rIns="109728" tIns="0" bIns="0"/>
-          <a:lstStyle/>
-          <a:p>
-            <a:pPr algn="ctr"/>
-            <a:r>
-              <a:rPr sz="2600" b="1">
-                <a:solidFill>
-                  <a:srgbClr val="062D3F"/>
-                </a:solidFill>
-                <a:latin typeface="Circe Bold"/>
-              </a:rPr>
-              <a:t>SWOT</a:t>
-            </a:r>
-          </a:p>
-          <a:p>
-            <a:pPr algn="ctr">
-              <a:spcBef>
-                <a:spcPts val="400"/>
-              </a:spcBef>
-            </a:pPr>
-            <a:r>
-              <a:rPr sz="1300" b="0">
-                <a:solidFill>
-                  <a:srgbClr val="062D3F"/>
-                </a:solidFill>
-                <a:latin typeface="Circe"/>
-              </a:rPr>
-              <a:t>сводит внешнее и внутреннее</a:t>
-            </a:r>
-          </a:p>
-        </p:txBody>
-      </p:sp>
-      <p:cxnSp>
-        <p:nvCxnSpPr>
-          <p:cNvPr id="233" name="Ствол"/>
-          <p:cNvCxnSpPr/>
-          <p:nvPr/>
-        </p:nvCxnSpPr>
-        <p:spPr>
-          <a:xfrm>
-            <a:off x="12298680" y="6007607"/>
-            <a:ext cx="320040" cy="0"/>
-          </a:xfrm>
-          <a:prstGeom prst="line">
-            <a:avLst/>
-          </a:prstGeom>
-          <a:ln w="25400">
-            <a:solidFill>
-              <a:srgbClr val="062D3F"/>
-            </a:solidFill>
-          </a:ln>
-        </p:spPr>
-      </p:cxnSp>
-      <p:cxnSp>
-        <p:nvCxnSpPr>
-          <p:cNvPr id="234" name="Ствол"/>
-          <p:cNvCxnSpPr/>
-          <p:nvPr/>
-        </p:nvCxnSpPr>
-        <p:spPr>
-          <a:xfrm>
-            <a:off x="12618720" y="3909059"/>
-            <a:ext cx="0" cy="4197097"/>
-          </a:xfrm>
-          <a:prstGeom prst="line">
-            <a:avLst/>
-          </a:prstGeom>
-          <a:ln w="25400">
-            <a:solidFill>
-              <a:srgbClr val="062D3F"/>
-            </a:solidFill>
-          </a:ln>
-        </p:spPr>
-      </p:cxnSp>
-      <p:cxnSp>
-        <p:nvCxnSpPr>
-          <p:cNvPr id="235" name="Ветвь 1"/>
-          <p:cNvCxnSpPr/>
-          <p:nvPr/>
-        </p:nvCxnSpPr>
-        <p:spPr>
-          <a:xfrm>
-            <a:off x="12618720" y="3909059"/>
-            <a:ext cx="320040" cy="0"/>
-          </a:xfrm>
-          <a:prstGeom prst="line">
-            <a:avLst/>
-          </a:prstGeom>
-          <a:ln w="25400">
-            <a:solidFill>
-              <a:srgbClr val="062D3F"/>
-            </a:solidFill>
-          </a:ln>
-        </p:spPr>
-      </p:cxnSp>
-      <p:sp>
-        <p:nvSpPr>
-          <p:cNvPr id="236" name="Стратегия Рост"/>
-          <p:cNvSpPr/>
-          <p:nvPr/>
-        </p:nvSpPr>
-        <p:spPr>
-          <a:xfrm>
-            <a:off x="12938760" y="3291839"/>
-            <a:ext cx="5010911" cy="1234439"/>
+            <a:off x="11887200" y="3291839"/>
+            <a:ext cx="6062471" cy="1234439"/>
           </a:xfrm>
           <a:prstGeom prst="roundRect">
             <a:avLst>
@@ -7420,7 +7347,7 @@
               </a:spcBef>
             </a:pPr>
             <a:r>
-              <a:rPr sz="1350" b="0">
+              <a:rPr sz="1400" b="0">
                 <a:solidFill>
                   <a:srgbClr val="062D3F"/>
                 </a:solidFill>
@@ -7433,13 +7360,13 @@
       </p:sp>
       <p:sp>
         <p:nvSpPr>
-          <p:cNvPr id="237" name="Акцент"/>
+          <p:cNvPr id="234" name="Акцент"/>
           <p:cNvSpPr/>
           <p:nvPr/>
         </p:nvSpPr>
         <p:spPr>
           <a:xfrm>
-            <a:off x="12938760" y="3428999"/>
+            <a:off x="11887200" y="3428999"/>
             <a:ext cx="82296" cy="960119"/>
           </a:xfrm>
           <a:prstGeom prst="rect">
@@ -7462,7 +7389,7 @@
       </p:sp>
       <p:sp>
         <p:nvSpPr>
-          <p:cNvPr id="238" name="Сочетание S + O"/>
+          <p:cNvPr id="235" name="Сочетание S + O"/>
           <p:cNvSpPr txBox="1"/>
           <p:nvPr/>
         </p:nvSpPr>
@@ -7497,14 +7424,14 @@
       </p:sp>
       <p:cxnSp>
         <p:nvCxnSpPr>
-          <p:cNvPr id="239" name="Ветвь 2"/>
+          <p:cNvPr id="236" name="Ветвь 2"/>
           <p:cNvCxnSpPr/>
           <p:nvPr/>
         </p:nvCxnSpPr>
         <p:spPr>
           <a:xfrm>
-            <a:off x="12618720" y="5308091"/>
-            <a:ext cx="320040" cy="0"/>
+            <a:off x="11430000" y="5308091"/>
+            <a:ext cx="457200" cy="0"/>
           </a:xfrm>
           <a:prstGeom prst="line">
             <a:avLst/>
@@ -7518,14 +7445,14 @@
       </p:cxnSp>
       <p:sp>
         <p:nvSpPr>
-          <p:cNvPr id="240" name="Стратегия Защита"/>
+          <p:cNvPr id="237" name="Стратегия Защита"/>
           <p:cNvSpPr/>
           <p:nvPr/>
         </p:nvSpPr>
         <p:spPr>
           <a:xfrm>
-            <a:off x="12938760" y="4690871"/>
-            <a:ext cx="5010911" cy="1234439"/>
+            <a:off x="11887200" y="4690871"/>
+            <a:ext cx="6062471" cy="1234439"/>
           </a:xfrm>
           <a:prstGeom prst="roundRect">
             <a:avLst>
@@ -7561,7 +7488,7 @@
               </a:spcBef>
             </a:pPr>
             <a:r>
-              <a:rPr sz="1350" b="0">
+              <a:rPr sz="1400" b="0">
                 <a:solidFill>
                   <a:srgbClr val="062D3F"/>
                 </a:solidFill>
@@ -7574,13 +7501,13 @@
       </p:sp>
       <p:sp>
         <p:nvSpPr>
-          <p:cNvPr id="241" name="Акцент"/>
+          <p:cNvPr id="238" name="Акцент"/>
           <p:cNvSpPr/>
           <p:nvPr/>
         </p:nvSpPr>
         <p:spPr>
           <a:xfrm>
-            <a:off x="12938760" y="4828031"/>
+            <a:off x="11887200" y="4828031"/>
             <a:ext cx="82296" cy="960119"/>
           </a:xfrm>
           <a:prstGeom prst="rect">
@@ -7603,7 +7530,7 @@
       </p:sp>
       <p:sp>
         <p:nvSpPr>
-          <p:cNvPr id="242" name="Сочетание S + T"/>
+          <p:cNvPr id="239" name="Сочетание S + T"/>
           <p:cNvSpPr txBox="1"/>
           <p:nvPr/>
         </p:nvSpPr>
@@ -7638,14 +7565,14 @@
       </p:sp>
       <p:cxnSp>
         <p:nvCxnSpPr>
-          <p:cNvPr id="243" name="Ветвь 3"/>
+          <p:cNvPr id="240" name="Ветвь 3"/>
           <p:cNvCxnSpPr/>
           <p:nvPr/>
         </p:nvCxnSpPr>
         <p:spPr>
           <a:xfrm>
-            <a:off x="12618720" y="6707123"/>
-            <a:ext cx="320040" cy="0"/>
+            <a:off x="11430000" y="6707123"/>
+            <a:ext cx="457200" cy="0"/>
           </a:xfrm>
           <a:prstGeom prst="line">
             <a:avLst/>
@@ -7659,14 +7586,14 @@
       </p:cxnSp>
       <p:sp>
         <p:nvSpPr>
-          <p:cNvPr id="244" name="Стратегия Укрепление"/>
+          <p:cNvPr id="241" name="Стратегия Укрепление"/>
           <p:cNvSpPr/>
           <p:nvPr/>
         </p:nvSpPr>
         <p:spPr>
           <a:xfrm>
-            <a:off x="12938760" y="6089903"/>
-            <a:ext cx="5010911" cy="1234439"/>
+            <a:off x="11887200" y="6089903"/>
+            <a:ext cx="6062471" cy="1234439"/>
           </a:xfrm>
           <a:prstGeom prst="roundRect">
             <a:avLst>
@@ -7702,7 +7629,7 @@
               </a:spcBef>
             </a:pPr>
             <a:r>
-              <a:rPr sz="1350" b="0">
+              <a:rPr sz="1400" b="0">
                 <a:solidFill>
                   <a:srgbClr val="062D3F"/>
                 </a:solidFill>
@@ -7715,13 +7642,13 @@
       </p:sp>
       <p:sp>
         <p:nvSpPr>
-          <p:cNvPr id="245" name="Акцент"/>
+          <p:cNvPr id="242" name="Акцент"/>
           <p:cNvSpPr/>
           <p:nvPr/>
         </p:nvSpPr>
         <p:spPr>
           <a:xfrm>
-            <a:off x="12938760" y="6227064"/>
+            <a:off x="11887200" y="6227064"/>
             <a:ext cx="82296" cy="960119"/>
           </a:xfrm>
           <a:prstGeom prst="rect">
@@ -7744,7 +7671,7 @@
       </p:sp>
       <p:sp>
         <p:nvSpPr>
-          <p:cNvPr id="246" name="Сочетание W + O"/>
+          <p:cNvPr id="243" name="Сочетание W + O"/>
           <p:cNvSpPr txBox="1"/>
           <p:nvPr/>
         </p:nvSpPr>
@@ -7779,14 +7706,14 @@
       </p:sp>
       <p:cxnSp>
         <p:nvCxnSpPr>
-          <p:cNvPr id="247" name="Ветвь 4"/>
+          <p:cNvPr id="244" name="Ветвь 4"/>
           <p:cNvCxnSpPr/>
           <p:nvPr/>
         </p:nvCxnSpPr>
         <p:spPr>
           <a:xfrm>
-            <a:off x="12618720" y="8106156"/>
-            <a:ext cx="320040" cy="0"/>
+            <a:off x="11430000" y="8106156"/>
+            <a:ext cx="457200" cy="0"/>
           </a:xfrm>
           <a:prstGeom prst="line">
             <a:avLst/>
@@ -7800,14 +7727,14 @@
       </p:cxnSp>
       <p:sp>
         <p:nvSpPr>
-          <p:cNvPr id="248" name="Стратегия Сжатие"/>
+          <p:cNvPr id="245" name="Стратегия Сжатие"/>
           <p:cNvSpPr/>
           <p:nvPr/>
         </p:nvSpPr>
         <p:spPr>
           <a:xfrm>
-            <a:off x="12938760" y="7488936"/>
-            <a:ext cx="5010911" cy="1234439"/>
+            <a:off x="11887200" y="7488936"/>
+            <a:ext cx="6062471" cy="1234439"/>
           </a:xfrm>
           <a:prstGeom prst="roundRect">
             <a:avLst>
@@ -7843,7 +7770,7 @@
               </a:spcBef>
             </a:pPr>
             <a:r>
-              <a:rPr sz="1350" b="0">
+              <a:rPr sz="1400" b="0">
                 <a:solidFill>
                   <a:srgbClr val="062D3F"/>
                 </a:solidFill>
@@ -7856,13 +7783,13 @@
       </p:sp>
       <p:sp>
         <p:nvSpPr>
-          <p:cNvPr id="249" name="Акцент"/>
+          <p:cNvPr id="246" name="Акцент"/>
           <p:cNvSpPr/>
           <p:nvPr/>
         </p:nvSpPr>
         <p:spPr>
           <a:xfrm>
-            <a:off x="12938760" y="7626096"/>
+            <a:off x="11887200" y="7626096"/>
             <a:ext cx="82296" cy="960119"/>
           </a:xfrm>
           <a:prstGeom prst="rect">
@@ -7885,7 +7812,7 @@
       </p:sp>
       <p:sp>
         <p:nvSpPr>
-          <p:cNvPr id="250" name="Сочетание W + T"/>
+          <p:cNvPr id="247" name="Сочетание W + T"/>
           <p:cNvSpPr txBox="1"/>
           <p:nvPr/>
         </p:nvSpPr>
@@ -7920,7 +7847,7 @@
       </p:sp>
       <p:sp>
         <p:nvSpPr>
-          <p:cNvPr id="251" name="Решения"/>
+          <p:cNvPr id="248" name="Решения"/>
           <p:cNvSpPr/>
           <p:nvPr/>
         </p:nvSpPr>
@@ -7960,7 +7887,7 @@
       </p:sp>
       <p:sp>
         <p:nvSpPr>
-          <p:cNvPr id="252" name="Решения текст"/>
+          <p:cNvPr id="249" name="Решения текст"/>
           <p:cNvSpPr txBox="1"/>
           <p:nvPr/>
         </p:nvSpPr>

</xml_diff>